<commit_message>
refactor: modularizar create-pptx.js e adicionar tratamento de fallback
</commit_message>
<xml_diff>
--- a/backend/presentation/SistemaConteudo-Afonteoculta.pptx
+++ b/backend/presentation/SistemaConteudo-Afonteoculta.pptx
@@ -9235,8 +9235,8 @@
         </p:nvSpPr>
         <p:spPr>
           <a:xfrm>
-            <a:off x="594360" y="960120"/>
-            <a:ext cx="2606040" cy="1417320"/>
+            <a:off x="594360" y="2606040"/>
+            <a:ext cx="914400" cy="1417320"/>
           </a:xfrm>
           <a:prstGeom prst="rect">
             <a:avLst/>
@@ -9370,8 +9370,8 @@
         </p:nvSpPr>
         <p:spPr>
           <a:xfrm>
-            <a:off x="3401568" y="960120"/>
-            <a:ext cx="2606040" cy="1417320"/>
+            <a:off x="3401568" y="2606040"/>
+            <a:ext cx="914400" cy="1417320"/>
           </a:xfrm>
           <a:prstGeom prst="rect">
             <a:avLst/>
@@ -9505,8 +9505,8 @@
         </p:nvSpPr>
         <p:spPr>
           <a:xfrm>
-            <a:off x="6208776" y="960120"/>
-            <a:ext cx="2606040" cy="1417320"/>
+            <a:off x="6208776" y="2606040"/>
+            <a:ext cx="914400" cy="1417320"/>
           </a:xfrm>
           <a:prstGeom prst="rect">
             <a:avLst/>
@@ -9640,8 +9640,8 @@
         </p:nvSpPr>
         <p:spPr>
           <a:xfrm>
-            <a:off x="594360" y="2542032"/>
-            <a:ext cx="2606040" cy="1417320"/>
+            <a:off x="594360" y="2606040"/>
+            <a:ext cx="914400" cy="1417320"/>
           </a:xfrm>
           <a:prstGeom prst="rect">
             <a:avLst/>
@@ -9775,8 +9775,8 @@
         </p:nvSpPr>
         <p:spPr>
           <a:xfrm>
-            <a:off x="3401568" y="2542032"/>
-            <a:ext cx="2606040" cy="1417320"/>
+            <a:off x="3401568" y="2606040"/>
+            <a:ext cx="914400" cy="1417320"/>
           </a:xfrm>
           <a:prstGeom prst="rect">
             <a:avLst/>
@@ -9910,8 +9910,8 @@
         </p:nvSpPr>
         <p:spPr>
           <a:xfrm>
-            <a:off x="6208776" y="2542032"/>
-            <a:ext cx="2606040" cy="1417320"/>
+            <a:off x="6208776" y="2606040"/>
+            <a:ext cx="914400" cy="1417320"/>
           </a:xfrm>
           <a:prstGeom prst="rect">
             <a:avLst/>

</xml_diff>